<commit_message>
Keep the poll join code out of anything published
The poll slide carries a ClassPulse QR and code. The session is open
permanently, so any published copy lets a stranger vote into the tally we
project at the room - which is the whole reason the link is slide-only.

The presenter decks keep the slide. build.py strips it when copying a deck into
docs/files/, and says so in its output rather than silently shipping something
different from what is on disk. The QR itself is written to slide-assets/,
which is gitignored.

Co-Authored-By: Claude Opus 5 (1M context) <noreply@anthropic.com>
</commit_message>
<xml_diff>
--- a/docs/files/UDL_Lens_Showcase_AI_half_v1.pptx
+++ b/docs/files/UDL_Lens_Showcase_AI_half_v1.pptx
@@ -5187,7 +5187,7 @@
           <a:lstStyle/>
           <a:p>
             <a:r>
-              <a:t>16 of 21 codes were wrong</a:t>
+              <a:t>One of these four is invented</a:t>
             </a:r>
           </a:p>
         </p:txBody>
@@ -5202,47 +5202,98 @@
             <p:ph idx="1"/>
           </p:nvPr>
         </p:nvSpPr>
-        <p:spPr/>
+        <p:spPr>
+          <a:xfrm>
+            <a:ext cx="7315200" cy="0"/>
+          </a:xfrm>
+        </p:spPr>
         <p:txBody>
           <a:bodyPr wrap="square"/>
           <a:lstStyle/>
           <a:p>
+            <a:r>
+              <a:rPr sz="2200"/>
+              <a:t>7.3 — Nurture joy and play</a:t>
+            </a:r>
+          </a:p>
+          <a:p>
             <a:pPr/>
             <a:r>
-              <a:rPr sz="2400" b="1">
-                <a:solidFill>
-                  <a:srgbClr val="0070C0"/>
-                </a:solidFill>
-              </a:rPr>
-              <a:t>Luke read the checkpoint data properly in May, and caught it</a:t>
+              <a:rPr sz="2200"/>
+              <a:t>8.3 — Foster collaboration, interdependence, and collective learning</a:t>
             </a:r>
           </a:p>
           <a:p>
             <a:pPr/>
             <a:r>
-              <a:rPr sz="2400" b="1"/>
-              <a:t>16 of our 21 UDL codes were wrong</a:t>
-            </a:r>
-          </a:p>
-          <a:p>
-            <a:pPr lvl="1"/>
-            <a:r>
-              <a:rPr sz="2000" b="0"/>
-              <a:t>UDL 2.2 leftovers, and codes the model appears to have invented</a:t>
+              <a:rPr sz="2200"/>
+              <a:t>4.3 — Technology requirements clearly stated</a:t>
             </a:r>
           </a:p>
           <a:p>
             <a:pPr/>
             <a:r>
-              <a:rPr sz="2400" b="0"/>
-              <a:t>He spotted it from a single entry: our “3.2 Explicit success criteria and rubric”</a:t>
-            </a:r>
-          </a:p>
-          <a:p>
-            <a:pPr lvl="1"/>
-            <a:r>
-              <a:rPr sz="2000" b="0"/>
-              <a:t>CAST’s actual 3.2 says nothing of the kind</a:t>
+              <a:rPr sz="2200"/>
+              <a:t>6.5 — Challenge exclusionary practices</a:t>
+            </a:r>
+          </a:p>
+        </p:txBody>
+      </p:sp>
+      <p:pic>
+        <p:nvPicPr>
+          <p:cNvPr id="4" name="Picture 3" descr="QR code to join the live poll at classpulse.eduserver.au, session code A1RHE7"/>
+          <p:cNvPicPr>
+            <a:picLocks noChangeAspect="1"/>
+          </p:cNvPicPr>
+          <p:nvPr/>
+        </p:nvPicPr>
+        <p:blipFill>
+          <a:blip r:embed="rId2"/>
+          <a:stretch>
+            <a:fillRect/>
+          </a:stretch>
+        </p:blipFill>
+        <p:spPr>
+          <a:xfrm>
+            <a:off x="8869680" y="2331720"/>
+            <a:ext cx="2468880" cy="2468880"/>
+          </a:xfrm>
+          <a:prstGeom prst="rect">
+            <a:avLst/>
+          </a:prstGeom>
+        </p:spPr>
+      </p:pic>
+      <p:sp>
+        <p:nvSpPr>
+          <p:cNvPr id="5" name="TextBox 4"/>
+          <p:cNvSpPr txBox="1"/>
+          <p:nvPr/>
+        </p:nvSpPr>
+        <p:spPr>
+          <a:xfrm>
+            <a:off x="8869680" y="4903470"/>
+            <a:ext cx="2468880" cy="822960"/>
+          </a:xfrm>
+          <a:prstGeom prst="rect">
+            <a:avLst/>
+          </a:prstGeom>
+          <a:noFill/>
+        </p:spPr>
+        <p:txBody>
+          <a:bodyPr wrap="square">
+            <a:spAutoFit/>
+          </a:bodyPr>
+          <a:lstStyle/>
+          <a:p>
+            <a:r>
+              <a:rPr sz="1400" b="0"/>
+              <a:t>classpulse.eduserver.au/join</a:t>
+            </a:r>
+          </a:p>
+          <a:p>
+            <a:r>
+              <a:rPr sz="1800" b="1"/>
+              <a:t>code A1RHE7</a:t>
             </a:r>
           </a:p>
         </p:txBody>
@@ -5281,202 +5332,62 @@
           <a:lstStyle/>
           <a:p>
             <a:r>
-              <a:t>It didn’t look wrong</a:t>
-            </a:r>
-          </a:p>
-        </p:txBody>
-      </p:sp>
-      <p:sp>
-        <p:nvSpPr>
-          <p:cNvPr id="3" name="Text Placeholder 2"/>
-          <p:cNvSpPr>
-            <a:spLocks noGrp="1"/>
-          </p:cNvSpPr>
-          <p:nvPr>
-            <p:ph type="body" idx="1"/>
-          </p:nvPr>
-        </p:nvSpPr>
-        <p:spPr/>
-        <p:txBody>
-          <a:bodyPr/>
-          <a:lstStyle/>
-          <a:p>
-            <a:r>
-              <a:rPr sz="2000" b="1">
+              <a:t>16 of 21 codes were wrong</a:t>
+            </a:r>
+          </a:p>
+        </p:txBody>
+      </p:sp>
+      <p:sp>
+        <p:nvSpPr>
+          <p:cNvPr id="3" name="Content Placeholder 2"/>
+          <p:cNvSpPr>
+            <a:spLocks noGrp="1"/>
+          </p:cNvSpPr>
+          <p:nvPr>
+            <p:ph idx="1"/>
+          </p:nvPr>
+        </p:nvSpPr>
+        <p:spPr/>
+        <p:txBody>
+          <a:bodyPr wrap="square"/>
+          <a:lstStyle/>
+          <a:p>
+            <a:pPr/>
+            <a:r>
+              <a:rPr sz="2400" b="1">
                 <a:solidFill>
                   <a:srgbClr val="0070C0"/>
                 </a:solidFill>
               </a:rPr>
-              <a:t>What we shipped</a:t>
-            </a:r>
-          </a:p>
-        </p:txBody>
-      </p:sp>
-      <p:sp>
-        <p:nvSpPr>
-          <p:cNvPr id="4" name="Content Placeholder 3"/>
-          <p:cNvSpPr>
-            <a:spLocks noGrp="1"/>
-          </p:cNvSpPr>
-          <p:nvPr>
-            <p:ph idx="2" sz="half"/>
-          </p:nvPr>
-        </p:nvSpPr>
-        <p:spPr/>
-        <p:txBody>
-          <a:bodyPr wrap="square"/>
-          <a:lstStyle/>
-          <a:p>
-            <a:r>
-              <a:rPr sz="1800" b="0"/>
-              <a:t>3.2  Explicit success criteria and rubric</a:t>
-            </a:r>
-          </a:p>
-          <a:p>
-            <a:pPr>
-              <a:spcBef>
-                <a:spcPts val="1000"/>
-              </a:spcBef>
-            </a:pPr>
-            <a:r>
-              <a:rPr sz="1800" b="0"/>
-              <a:t>1.3  Brief meets accessibility standards</a:t>
-            </a:r>
-          </a:p>
-          <a:p>
-            <a:pPr>
-              <a:spcBef>
-                <a:spcPts val="1000"/>
-              </a:spcBef>
-            </a:pPr>
-            <a:r>
-              <a:rPr sz="1800" b="0"/>
-              <a:t>9.2  No assumed socioeconomic advantage</a:t>
-            </a:r>
-          </a:p>
-          <a:p>
-            <a:pPr>
-              <a:spcBef>
-                <a:spcPts val="1000"/>
-              </a:spcBef>
-            </a:pPr>
-            <a:r>
-              <a:rPr sz="1800" b="1"/>
-              <a:t>4.3  Technology requirements clearly stated</a:t>
-            </a:r>
-          </a:p>
-        </p:txBody>
-      </p:sp>
-      <p:sp>
-        <p:nvSpPr>
-          <p:cNvPr id="5" name="Text Placeholder 4"/>
-          <p:cNvSpPr>
-            <a:spLocks noGrp="1"/>
-          </p:cNvSpPr>
-          <p:nvPr>
-            <p:ph type="body" idx="3" sz="quarter"/>
-          </p:nvPr>
-        </p:nvSpPr>
-        <p:spPr/>
-        <p:txBody>
-          <a:bodyPr/>
-          <a:lstStyle/>
-          <a:p>
-            <a:r>
-              <a:rPr sz="2000" b="1">
-                <a:solidFill>
-                  <a:srgbClr val="0070C0"/>
-                </a:solidFill>
-              </a:rPr>
-              <a:t>What UDL 3.0 actually says</a:t>
-            </a:r>
-          </a:p>
-        </p:txBody>
-      </p:sp>
-      <p:sp>
-        <p:nvSpPr>
-          <p:cNvPr id="6" name="Content Placeholder 5"/>
-          <p:cNvSpPr>
-            <a:spLocks noGrp="1"/>
-          </p:cNvSpPr>
-          <p:nvPr>
-            <p:ph idx="4" sz="quarter"/>
-          </p:nvPr>
-        </p:nvSpPr>
-        <p:spPr/>
-        <p:txBody>
-          <a:bodyPr wrap="square"/>
-          <a:lstStyle/>
-          <a:p>
-            <a:r>
-              <a:rPr sz="1800" b="0"/>
-              <a:t>Highlight patterns and big ideas</a:t>
-            </a:r>
-          </a:p>
-          <a:p>
-            <a:pPr>
-              <a:spcBef>
-                <a:spcPts val="1000"/>
-              </a:spcBef>
-            </a:pPr>
-            <a:r>
-              <a:rPr sz="1800" b="0"/>
-              <a:t>Represent diverse perspectives and identities</a:t>
-            </a:r>
-          </a:p>
-          <a:p>
-            <a:pPr>
-              <a:spcBef>
-                <a:spcPts val="1000"/>
-              </a:spcBef>
-            </a:pPr>
-            <a:r>
-              <a:rPr sz="1800" b="0"/>
-              <a:t>Develop awareness of self and others</a:t>
-            </a:r>
-          </a:p>
-          <a:p>
-            <a:pPr>
-              <a:spcBef>
-                <a:spcPts val="1000"/>
-              </a:spcBef>
-            </a:pPr>
-            <a:r>
-              <a:rPr sz="1800" b="1"/>
-              <a:t>There is no 4.3. Guideline 4 stops at 4.2</a:t>
-            </a:r>
-          </a:p>
-        </p:txBody>
-      </p:sp>
-      <p:sp>
-        <p:nvSpPr>
-          <p:cNvPr id="7" name="TextBox 6"/>
-          <p:cNvSpPr txBox="1"/>
-          <p:nvPr/>
-        </p:nvSpPr>
-        <p:spPr>
-          <a:xfrm>
-            <a:off x="841248" y="4892040"/>
-            <a:ext cx="10515600" cy="548640"/>
-          </a:xfrm>
-          <a:prstGeom prst="rect">
-            <a:avLst/>
-          </a:prstGeom>
-          <a:noFill/>
-        </p:spPr>
-        <p:txBody>
-          <a:bodyPr wrap="square" lIns="0" tIns="0" bIns="0">
-            <a:spAutoFit/>
-          </a:bodyPr>
-          <a:lstStyle/>
-          <a:p>
-            <a:r>
-              <a:rPr sz="2000" b="1">
-                <a:solidFill>
-                  <a:srgbClr val="0070C0"/>
-                </a:solidFill>
-              </a:rPr>
-              <a:t>Plausible, well formatted, confidently numbered, and wrong.</a:t>
+              <a:t>Luke read the checkpoint data properly in May, and caught it</a:t>
+            </a:r>
+          </a:p>
+          <a:p>
+            <a:pPr/>
+            <a:r>
+              <a:rPr sz="2400" b="1"/>
+              <a:t>16 of our 21 UDL codes were wrong</a:t>
+            </a:r>
+          </a:p>
+          <a:p>
+            <a:pPr lvl="1"/>
+            <a:r>
+              <a:rPr sz="2000" b="0"/>
+              <a:t>UDL 2.2 leftovers, and codes the model appears to have invented</a:t>
+            </a:r>
+          </a:p>
+          <a:p>
+            <a:pPr/>
+            <a:r>
+              <a:rPr sz="2400" b="0"/>
+              <a:t>He spotted it from a single entry: our “3.2 Explicit success criteria and rubric”</a:t>
+            </a:r>
+          </a:p>
+          <a:p>
+            <a:pPr lvl="1"/>
+            <a:r>
+              <a:rPr sz="2000" b="0"/>
+              <a:t>CAST’s actual 3.2 says nothing of the kind</a:t>
             </a:r>
           </a:p>
         </p:txBody>
@@ -5515,55 +5426,202 @@
           <a:lstStyle/>
           <a:p>
             <a:r>
-              <a:t>The reset</a:t>
-            </a:r>
-          </a:p>
-        </p:txBody>
-      </p:sp>
-      <p:sp>
-        <p:nvSpPr>
-          <p:cNvPr id="3" name="Content Placeholder 2"/>
-          <p:cNvSpPr>
-            <a:spLocks noGrp="1"/>
-          </p:cNvSpPr>
-          <p:nvPr>
-            <p:ph idx="1"/>
-          </p:nvPr>
-        </p:nvSpPr>
-        <p:spPr/>
-        <p:txBody>
-          <a:bodyPr wrap="square"/>
-          <a:lstStyle/>
-          <a:p>
-            <a:pPr/>
-            <a:r>
-              <a:rPr sz="2400" b="0"/>
-              <a:t>Stripped back to six – only considerations Luke had verified against CAST</a:t>
-            </a:r>
-          </a:p>
-          <a:p>
-            <a:pPr/>
-            <a:r>
-              <a:rPr sz="2400" b="0"/>
-              <a:t>Made the codes checkable – every code now validates against a canonical UDL 3.0 table</a:t>
-            </a:r>
-          </a:p>
-          <a:p>
-            <a:pPr/>
-            <a:r>
-              <a:rPr sz="2400" b="1">
+              <a:t>It didn’t look wrong</a:t>
+            </a:r>
+          </a:p>
+        </p:txBody>
+      </p:sp>
+      <p:sp>
+        <p:nvSpPr>
+          <p:cNvPr id="3" name="Text Placeholder 2"/>
+          <p:cNvSpPr>
+            <a:spLocks noGrp="1"/>
+          </p:cNvSpPr>
+          <p:nvPr>
+            <p:ph type="body" idx="1"/>
+          </p:nvPr>
+        </p:nvSpPr>
+        <p:spPr/>
+        <p:txBody>
+          <a:bodyPr/>
+          <a:lstStyle/>
+          <a:p>
+            <a:r>
+              <a:rPr sz="2000" b="1">
                 <a:solidFill>
                   <a:srgbClr val="0070C0"/>
                 </a:solidFill>
               </a:rPr>
-              <a:t>Took the pedagogy off the model – the practices are written by someone who teaches</a:t>
-            </a:r>
-          </a:p>
-          <a:p>
-            <a:pPr/>
-            <a:r>
-              <a:rPr sz="2400" b="0"/>
-              <a:t>Kept the receipts – the 21-checkpoint version is still in git history</a:t>
+              <a:t>What we shipped</a:t>
+            </a:r>
+          </a:p>
+        </p:txBody>
+      </p:sp>
+      <p:sp>
+        <p:nvSpPr>
+          <p:cNvPr id="4" name="Content Placeholder 3"/>
+          <p:cNvSpPr>
+            <a:spLocks noGrp="1"/>
+          </p:cNvSpPr>
+          <p:nvPr>
+            <p:ph idx="2" sz="half"/>
+          </p:nvPr>
+        </p:nvSpPr>
+        <p:spPr/>
+        <p:txBody>
+          <a:bodyPr wrap="square"/>
+          <a:lstStyle/>
+          <a:p>
+            <a:r>
+              <a:rPr sz="1800" b="0"/>
+              <a:t>3.2  Explicit success criteria and rubric</a:t>
+            </a:r>
+          </a:p>
+          <a:p>
+            <a:pPr>
+              <a:spcBef>
+                <a:spcPts val="1000"/>
+              </a:spcBef>
+            </a:pPr>
+            <a:r>
+              <a:rPr sz="1800" b="0"/>
+              <a:t>1.3  Brief meets accessibility standards</a:t>
+            </a:r>
+          </a:p>
+          <a:p>
+            <a:pPr>
+              <a:spcBef>
+                <a:spcPts val="1000"/>
+              </a:spcBef>
+            </a:pPr>
+            <a:r>
+              <a:rPr sz="1800" b="0"/>
+              <a:t>9.2  No assumed socioeconomic advantage</a:t>
+            </a:r>
+          </a:p>
+          <a:p>
+            <a:pPr>
+              <a:spcBef>
+                <a:spcPts val="1000"/>
+              </a:spcBef>
+            </a:pPr>
+            <a:r>
+              <a:rPr sz="1800" b="1"/>
+              <a:t>4.3  Technology requirements clearly stated</a:t>
+            </a:r>
+          </a:p>
+        </p:txBody>
+      </p:sp>
+      <p:sp>
+        <p:nvSpPr>
+          <p:cNvPr id="5" name="Text Placeholder 4"/>
+          <p:cNvSpPr>
+            <a:spLocks noGrp="1"/>
+          </p:cNvSpPr>
+          <p:nvPr>
+            <p:ph type="body" idx="3" sz="quarter"/>
+          </p:nvPr>
+        </p:nvSpPr>
+        <p:spPr/>
+        <p:txBody>
+          <a:bodyPr/>
+          <a:lstStyle/>
+          <a:p>
+            <a:r>
+              <a:rPr sz="2000" b="1">
+                <a:solidFill>
+                  <a:srgbClr val="0070C0"/>
+                </a:solidFill>
+              </a:rPr>
+              <a:t>What UDL 3.0 actually says</a:t>
+            </a:r>
+          </a:p>
+        </p:txBody>
+      </p:sp>
+      <p:sp>
+        <p:nvSpPr>
+          <p:cNvPr id="6" name="Content Placeholder 5"/>
+          <p:cNvSpPr>
+            <a:spLocks noGrp="1"/>
+          </p:cNvSpPr>
+          <p:nvPr>
+            <p:ph idx="4" sz="quarter"/>
+          </p:nvPr>
+        </p:nvSpPr>
+        <p:spPr/>
+        <p:txBody>
+          <a:bodyPr wrap="square"/>
+          <a:lstStyle/>
+          <a:p>
+            <a:r>
+              <a:rPr sz="1800" b="0"/>
+              <a:t>Highlight patterns and big ideas</a:t>
+            </a:r>
+          </a:p>
+          <a:p>
+            <a:pPr>
+              <a:spcBef>
+                <a:spcPts val="1000"/>
+              </a:spcBef>
+            </a:pPr>
+            <a:r>
+              <a:rPr sz="1800" b="0"/>
+              <a:t>Represent diverse perspectives and identities</a:t>
+            </a:r>
+          </a:p>
+          <a:p>
+            <a:pPr>
+              <a:spcBef>
+                <a:spcPts val="1000"/>
+              </a:spcBef>
+            </a:pPr>
+            <a:r>
+              <a:rPr sz="1800" b="0"/>
+              <a:t>Develop awareness of self and others</a:t>
+            </a:r>
+          </a:p>
+          <a:p>
+            <a:pPr>
+              <a:spcBef>
+                <a:spcPts val="1000"/>
+              </a:spcBef>
+            </a:pPr>
+            <a:r>
+              <a:rPr sz="1800" b="1"/>
+              <a:t>There is no 4.3. Guideline 4 stops at 4.2</a:t>
+            </a:r>
+          </a:p>
+        </p:txBody>
+      </p:sp>
+      <p:sp>
+        <p:nvSpPr>
+          <p:cNvPr id="7" name="TextBox 6"/>
+          <p:cNvSpPr txBox="1"/>
+          <p:nvPr/>
+        </p:nvSpPr>
+        <p:spPr>
+          <a:xfrm>
+            <a:off x="841248" y="4892040"/>
+            <a:ext cx="10515600" cy="548640"/>
+          </a:xfrm>
+          <a:prstGeom prst="rect">
+            <a:avLst/>
+          </a:prstGeom>
+          <a:noFill/>
+        </p:spPr>
+        <p:txBody>
+          <a:bodyPr wrap="square" lIns="0" tIns="0" bIns="0">
+            <a:spAutoFit/>
+          </a:bodyPr>
+          <a:lstStyle/>
+          <a:p>
+            <a:r>
+              <a:rPr sz="2000" b="1">
+                <a:solidFill>
+                  <a:srgbClr val="0070C0"/>
+                </a:solidFill>
+              </a:rPr>
+              <a:t>Plausible, well formatted, confidently numbered, and wrong.</a:t>
             </a:r>
           </a:p>
         </p:txBody>
@@ -5602,7 +5660,7 @@
           <a:lstStyle/>
           <a:p>
             <a:r>
-              <a:t>It happened again</a:t>
+              <a:t>The reset</a:t>
             </a:r>
           </a:p>
         </p:txBody>
@@ -5625,14 +5683,14 @@
             <a:pPr/>
             <a:r>
               <a:rPr sz="2400" b="0"/>
-              <a:t>Two weeks ago, drafting an expansion to more assessment types</a:t>
-            </a:r>
-          </a:p>
-          <a:p>
-            <a:pPr lvl="1"/>
-            <a:r>
-              <a:rPr sz="2000" b="0"/>
-              <a:t>UDL 2.2 names again, and two codes that had moved between versions</a:t>
+              <a:t>Stripped back to six – only considerations Luke had verified against CAST</a:t>
+            </a:r>
+          </a:p>
+          <a:p>
+            <a:pPr/>
+            <a:r>
+              <a:rPr sz="2400" b="0"/>
+              <a:t>Made the codes checkable – every code now validates against a canonical UDL 3.0 table</a:t>
             </a:r>
           </a:p>
           <a:p>
@@ -5643,14 +5701,14 @@
                   <a:srgbClr val="0070C0"/>
                 </a:solidFill>
               </a:rPr>
-              <a:t>Caught by the check we built the first time, not by anyone being careful</a:t>
+              <a:t>Took the pedagogy off the model – the practices are written by someone who teaches</a:t>
             </a:r>
           </a:p>
           <a:p>
             <a:pPr/>
             <a:r>
-              <a:rPr sz="2400" b="1"/>
-              <a:t>This isn’t a bug you fix once. It’s a property you design around</a:t>
+              <a:rPr sz="2400" b="0"/>
+              <a:t>Kept the receipts – the 21-checkpoint version is still in git history</a:t>
             </a:r>
           </a:p>
         </p:txBody>
@@ -5664,6 +5722,93 @@
 </file>
 
 <file path=ppt/slides/slide8.xml><?xml version="1.0" encoding="utf-8"?>
+<p:sld xmlns:a="http://schemas.openxmlformats.org/drawingml/2006/main" xmlns:p="http://schemas.openxmlformats.org/presentationml/2006/main" xmlns:r="http://schemas.openxmlformats.org/officeDocument/2006/relationships">
+  <p:cSld>
+    <p:spTree>
+      <p:nvGrpSpPr>
+        <p:cNvPr id="1" name=""/>
+        <p:cNvGrpSpPr/>
+        <p:nvPr/>
+      </p:nvGrpSpPr>
+      <p:grpSpPr/>
+      <p:sp>
+        <p:nvSpPr>
+          <p:cNvPr id="2" name="Title 1"/>
+          <p:cNvSpPr>
+            <a:spLocks noGrp="1"/>
+          </p:cNvSpPr>
+          <p:nvPr>
+            <p:ph type="title"/>
+          </p:nvPr>
+        </p:nvSpPr>
+        <p:spPr/>
+        <p:txBody>
+          <a:bodyPr/>
+          <a:lstStyle/>
+          <a:p>
+            <a:r>
+              <a:t>It happened again</a:t>
+            </a:r>
+          </a:p>
+        </p:txBody>
+      </p:sp>
+      <p:sp>
+        <p:nvSpPr>
+          <p:cNvPr id="3" name="Content Placeholder 2"/>
+          <p:cNvSpPr>
+            <a:spLocks noGrp="1"/>
+          </p:cNvSpPr>
+          <p:nvPr>
+            <p:ph idx="1"/>
+          </p:nvPr>
+        </p:nvSpPr>
+        <p:spPr/>
+        <p:txBody>
+          <a:bodyPr wrap="square"/>
+          <a:lstStyle/>
+          <a:p>
+            <a:pPr/>
+            <a:r>
+              <a:rPr sz="2400" b="0"/>
+              <a:t>Two weeks ago, drafting an expansion to more assessment types</a:t>
+            </a:r>
+          </a:p>
+          <a:p>
+            <a:pPr lvl="1"/>
+            <a:r>
+              <a:rPr sz="2000" b="0"/>
+              <a:t>UDL 2.2 names again, and two codes that had moved between versions</a:t>
+            </a:r>
+          </a:p>
+          <a:p>
+            <a:pPr/>
+            <a:r>
+              <a:rPr sz="2400" b="1">
+                <a:solidFill>
+                  <a:srgbClr val="0070C0"/>
+                </a:solidFill>
+              </a:rPr>
+              <a:t>Caught by the check we built the first time, not by anyone being careful</a:t>
+            </a:r>
+          </a:p>
+          <a:p>
+            <a:pPr/>
+            <a:r>
+              <a:rPr sz="2400" b="1"/>
+              <a:t>This isn’t a bug you fix once. It’s a property you design around</a:t>
+            </a:r>
+          </a:p>
+        </p:txBody>
+      </p:sp>
+    </p:spTree>
+  </p:cSld>
+  <p:clrMapOvr>
+    <a:masterClrMapping/>
+  </p:clrMapOvr>
+</p:sld>
+</file>
+
+<file path=ppt/slides/slide9.xml><?xml version="1.0" encoding="utf-8"?>
 <p:sld xmlns:a="http://schemas.openxmlformats.org/drawingml/2006/main" xmlns:p="http://schemas.openxmlformats.org/presentationml/2006/main" xmlns:r="http://schemas.openxmlformats.org/officeDocument/2006/relationships">
   <p:cSld>
     <p:spTree>

</xml_diff>

<commit_message>
Publish the deck complete, poll slide included
Reverts the stripping added a commit ago. The published deck is the presenters'
backup copy - if the laptop dies, that download is the fallback - and a backup
missing a slide is not a backup.

The trade-off is real but small and now deliberate: the join code is findable by
anyone who opens the file, so a stranger could vote into the tally. Mitigation
is procedural rather than technical - clear the session's responses on the
morning of each event, which is already in the run sheet.

Co-Authored-By: Claude Opus 5 (1M context) <noreply@anthropic.com>
</commit_message>
<xml_diff>
--- a/docs/files/UDL_Lens_Showcase_AI_half_v1.pptx
+++ b/docs/files/UDL_Lens_Showcase_AI_half_v1.pptx
@@ -11,6 +11,7 @@
     <p:sldId id="256" r:id="rId9"/>
     <p:sldId id="257" r:id="rId10"/>
     <p:sldId id="258" r:id="rId11"/>
+    <p:sldId id="264" r:id="rId17"/>
     <p:sldId id="259" r:id="rId12"/>
     <p:sldId id="260" r:id="rId13"/>
     <p:sldId id="261" r:id="rId14"/>
@@ -5187,6 +5188,620 @@
           <a:lstStyle/>
           <a:p>
             <a:r>
+              <a:t>16 of 21 codes were wrong</a:t>
+            </a:r>
+          </a:p>
+        </p:txBody>
+      </p:sp>
+      <p:sp>
+        <p:nvSpPr>
+          <p:cNvPr id="3" name="Content Placeholder 2"/>
+          <p:cNvSpPr>
+            <a:spLocks noGrp="1"/>
+          </p:cNvSpPr>
+          <p:nvPr>
+            <p:ph idx="1"/>
+          </p:nvPr>
+        </p:nvSpPr>
+        <p:spPr/>
+        <p:txBody>
+          <a:bodyPr wrap="square"/>
+          <a:lstStyle/>
+          <a:p>
+            <a:pPr/>
+            <a:r>
+              <a:rPr sz="2400" b="1">
+                <a:solidFill>
+                  <a:srgbClr val="0070C0"/>
+                </a:solidFill>
+              </a:rPr>
+              <a:t>Luke read the checkpoint data properly in May, and caught it</a:t>
+            </a:r>
+          </a:p>
+          <a:p>
+            <a:pPr/>
+            <a:r>
+              <a:rPr sz="2400" b="1"/>
+              <a:t>16 of our 21 UDL codes were wrong</a:t>
+            </a:r>
+          </a:p>
+          <a:p>
+            <a:pPr lvl="1"/>
+            <a:r>
+              <a:rPr sz="2000" b="0"/>
+              <a:t>UDL 2.2 leftovers, and codes the model appears to have invented</a:t>
+            </a:r>
+          </a:p>
+          <a:p>
+            <a:pPr/>
+            <a:r>
+              <a:rPr sz="2400" b="0"/>
+              <a:t>He spotted it from a single entry: our “3.2 Explicit success criteria and rubric”</a:t>
+            </a:r>
+          </a:p>
+          <a:p>
+            <a:pPr lvl="1"/>
+            <a:r>
+              <a:rPr sz="2000" b="0"/>
+              <a:t>CAST’s actual 3.2 says nothing of the kind</a:t>
+            </a:r>
+          </a:p>
+        </p:txBody>
+      </p:sp>
+    </p:spTree>
+  </p:cSld>
+  <p:clrMapOvr>
+    <a:masterClrMapping/>
+  </p:clrMapOvr>
+</p:sld>
+</file>
+
+<file path=ppt/slides/slide5.xml><?xml version="1.0" encoding="utf-8"?>
+<p:sld xmlns:a="http://schemas.openxmlformats.org/drawingml/2006/main" xmlns:p="http://schemas.openxmlformats.org/presentationml/2006/main" xmlns:r="http://schemas.openxmlformats.org/officeDocument/2006/relationships">
+  <p:cSld>
+    <p:spTree>
+      <p:nvGrpSpPr>
+        <p:cNvPr id="1" name=""/>
+        <p:cNvGrpSpPr/>
+        <p:nvPr/>
+      </p:nvGrpSpPr>
+      <p:grpSpPr/>
+      <p:sp>
+        <p:nvSpPr>
+          <p:cNvPr id="2" name="Title 1"/>
+          <p:cNvSpPr>
+            <a:spLocks noGrp="1"/>
+          </p:cNvSpPr>
+          <p:nvPr>
+            <p:ph type="title"/>
+          </p:nvPr>
+        </p:nvSpPr>
+        <p:spPr/>
+        <p:txBody>
+          <a:bodyPr/>
+          <a:lstStyle/>
+          <a:p>
+            <a:r>
+              <a:t>It didn’t look wrong</a:t>
+            </a:r>
+          </a:p>
+        </p:txBody>
+      </p:sp>
+      <p:sp>
+        <p:nvSpPr>
+          <p:cNvPr id="3" name="Text Placeholder 2"/>
+          <p:cNvSpPr>
+            <a:spLocks noGrp="1"/>
+          </p:cNvSpPr>
+          <p:nvPr>
+            <p:ph type="body" idx="1"/>
+          </p:nvPr>
+        </p:nvSpPr>
+        <p:spPr/>
+        <p:txBody>
+          <a:bodyPr/>
+          <a:lstStyle/>
+          <a:p>
+            <a:r>
+              <a:rPr sz="2000" b="1">
+                <a:solidFill>
+                  <a:srgbClr val="0070C0"/>
+                </a:solidFill>
+              </a:rPr>
+              <a:t>What we shipped</a:t>
+            </a:r>
+          </a:p>
+        </p:txBody>
+      </p:sp>
+      <p:sp>
+        <p:nvSpPr>
+          <p:cNvPr id="4" name="Content Placeholder 3"/>
+          <p:cNvSpPr>
+            <a:spLocks noGrp="1"/>
+          </p:cNvSpPr>
+          <p:nvPr>
+            <p:ph idx="2" sz="half"/>
+          </p:nvPr>
+        </p:nvSpPr>
+        <p:spPr/>
+        <p:txBody>
+          <a:bodyPr wrap="square"/>
+          <a:lstStyle/>
+          <a:p>
+            <a:r>
+              <a:rPr sz="1800" b="0"/>
+              <a:t>3.2  Explicit success criteria and rubric</a:t>
+            </a:r>
+          </a:p>
+          <a:p>
+            <a:pPr>
+              <a:spcBef>
+                <a:spcPts val="1000"/>
+              </a:spcBef>
+            </a:pPr>
+            <a:r>
+              <a:rPr sz="1800" b="0"/>
+              <a:t>1.3  Brief meets accessibility standards</a:t>
+            </a:r>
+          </a:p>
+          <a:p>
+            <a:pPr>
+              <a:spcBef>
+                <a:spcPts val="1000"/>
+              </a:spcBef>
+            </a:pPr>
+            <a:r>
+              <a:rPr sz="1800" b="0"/>
+              <a:t>9.2  No assumed socioeconomic advantage</a:t>
+            </a:r>
+          </a:p>
+          <a:p>
+            <a:pPr>
+              <a:spcBef>
+                <a:spcPts val="1000"/>
+              </a:spcBef>
+            </a:pPr>
+            <a:r>
+              <a:rPr sz="1800" b="1"/>
+              <a:t>4.3  Technology requirements clearly stated</a:t>
+            </a:r>
+          </a:p>
+        </p:txBody>
+      </p:sp>
+      <p:sp>
+        <p:nvSpPr>
+          <p:cNvPr id="5" name="Text Placeholder 4"/>
+          <p:cNvSpPr>
+            <a:spLocks noGrp="1"/>
+          </p:cNvSpPr>
+          <p:nvPr>
+            <p:ph type="body" idx="3" sz="quarter"/>
+          </p:nvPr>
+        </p:nvSpPr>
+        <p:spPr/>
+        <p:txBody>
+          <a:bodyPr/>
+          <a:lstStyle/>
+          <a:p>
+            <a:r>
+              <a:rPr sz="2000" b="1">
+                <a:solidFill>
+                  <a:srgbClr val="0070C0"/>
+                </a:solidFill>
+              </a:rPr>
+              <a:t>What UDL 3.0 actually says</a:t>
+            </a:r>
+          </a:p>
+        </p:txBody>
+      </p:sp>
+      <p:sp>
+        <p:nvSpPr>
+          <p:cNvPr id="6" name="Content Placeholder 5"/>
+          <p:cNvSpPr>
+            <a:spLocks noGrp="1"/>
+          </p:cNvSpPr>
+          <p:nvPr>
+            <p:ph idx="4" sz="quarter"/>
+          </p:nvPr>
+        </p:nvSpPr>
+        <p:spPr/>
+        <p:txBody>
+          <a:bodyPr wrap="square"/>
+          <a:lstStyle/>
+          <a:p>
+            <a:r>
+              <a:rPr sz="1800" b="0"/>
+              <a:t>Highlight patterns and big ideas</a:t>
+            </a:r>
+          </a:p>
+          <a:p>
+            <a:pPr>
+              <a:spcBef>
+                <a:spcPts val="1000"/>
+              </a:spcBef>
+            </a:pPr>
+            <a:r>
+              <a:rPr sz="1800" b="0"/>
+              <a:t>Represent diverse perspectives and identities</a:t>
+            </a:r>
+          </a:p>
+          <a:p>
+            <a:pPr>
+              <a:spcBef>
+                <a:spcPts val="1000"/>
+              </a:spcBef>
+            </a:pPr>
+            <a:r>
+              <a:rPr sz="1800" b="0"/>
+              <a:t>Develop awareness of self and others</a:t>
+            </a:r>
+          </a:p>
+          <a:p>
+            <a:pPr>
+              <a:spcBef>
+                <a:spcPts val="1000"/>
+              </a:spcBef>
+            </a:pPr>
+            <a:r>
+              <a:rPr sz="1800" b="1"/>
+              <a:t>There is no 4.3. Guideline 4 stops at 4.2</a:t>
+            </a:r>
+          </a:p>
+        </p:txBody>
+      </p:sp>
+      <p:sp>
+        <p:nvSpPr>
+          <p:cNvPr id="7" name="TextBox 6"/>
+          <p:cNvSpPr txBox="1"/>
+          <p:nvPr/>
+        </p:nvSpPr>
+        <p:spPr>
+          <a:xfrm>
+            <a:off x="841248" y="4892040"/>
+            <a:ext cx="10515600" cy="548640"/>
+          </a:xfrm>
+          <a:prstGeom prst="rect">
+            <a:avLst/>
+          </a:prstGeom>
+          <a:noFill/>
+        </p:spPr>
+        <p:txBody>
+          <a:bodyPr wrap="square" lIns="0" tIns="0" bIns="0">
+            <a:spAutoFit/>
+          </a:bodyPr>
+          <a:lstStyle/>
+          <a:p>
+            <a:r>
+              <a:rPr sz="2000" b="1">
+                <a:solidFill>
+                  <a:srgbClr val="0070C0"/>
+                </a:solidFill>
+              </a:rPr>
+              <a:t>Plausible, well formatted, confidently numbered, and wrong.</a:t>
+            </a:r>
+          </a:p>
+        </p:txBody>
+      </p:sp>
+    </p:spTree>
+  </p:cSld>
+  <p:clrMapOvr>
+    <a:masterClrMapping/>
+  </p:clrMapOvr>
+</p:sld>
+</file>
+
+<file path=ppt/slides/slide6.xml><?xml version="1.0" encoding="utf-8"?>
+<p:sld xmlns:a="http://schemas.openxmlformats.org/drawingml/2006/main" xmlns:p="http://schemas.openxmlformats.org/presentationml/2006/main" xmlns:r="http://schemas.openxmlformats.org/officeDocument/2006/relationships">
+  <p:cSld>
+    <p:spTree>
+      <p:nvGrpSpPr>
+        <p:cNvPr id="1" name=""/>
+        <p:cNvGrpSpPr/>
+        <p:nvPr/>
+      </p:nvGrpSpPr>
+      <p:grpSpPr/>
+      <p:sp>
+        <p:nvSpPr>
+          <p:cNvPr id="2" name="Title 1"/>
+          <p:cNvSpPr>
+            <a:spLocks noGrp="1"/>
+          </p:cNvSpPr>
+          <p:nvPr>
+            <p:ph type="title"/>
+          </p:nvPr>
+        </p:nvSpPr>
+        <p:spPr/>
+        <p:txBody>
+          <a:bodyPr/>
+          <a:lstStyle/>
+          <a:p>
+            <a:r>
+              <a:t>The reset</a:t>
+            </a:r>
+          </a:p>
+        </p:txBody>
+      </p:sp>
+      <p:sp>
+        <p:nvSpPr>
+          <p:cNvPr id="3" name="Content Placeholder 2"/>
+          <p:cNvSpPr>
+            <a:spLocks noGrp="1"/>
+          </p:cNvSpPr>
+          <p:nvPr>
+            <p:ph idx="1"/>
+          </p:nvPr>
+        </p:nvSpPr>
+        <p:spPr/>
+        <p:txBody>
+          <a:bodyPr wrap="square"/>
+          <a:lstStyle/>
+          <a:p>
+            <a:pPr/>
+            <a:r>
+              <a:rPr sz="2400" b="0"/>
+              <a:t>Stripped back to six – only considerations Luke had verified against CAST</a:t>
+            </a:r>
+          </a:p>
+          <a:p>
+            <a:pPr/>
+            <a:r>
+              <a:rPr sz="2400" b="0"/>
+              <a:t>Made the codes checkable – every code now validates against a canonical UDL 3.0 table</a:t>
+            </a:r>
+          </a:p>
+          <a:p>
+            <a:pPr/>
+            <a:r>
+              <a:rPr sz="2400" b="1">
+                <a:solidFill>
+                  <a:srgbClr val="0070C0"/>
+                </a:solidFill>
+              </a:rPr>
+              <a:t>Took the pedagogy off the model – the practices are written by someone who teaches</a:t>
+            </a:r>
+          </a:p>
+          <a:p>
+            <a:pPr/>
+            <a:r>
+              <a:rPr sz="2400" b="0"/>
+              <a:t>Kept the receipts – the 21-checkpoint version is still in git history</a:t>
+            </a:r>
+          </a:p>
+        </p:txBody>
+      </p:sp>
+    </p:spTree>
+  </p:cSld>
+  <p:clrMapOvr>
+    <a:masterClrMapping/>
+  </p:clrMapOvr>
+</p:sld>
+</file>
+
+<file path=ppt/slides/slide7.xml><?xml version="1.0" encoding="utf-8"?>
+<p:sld xmlns:a="http://schemas.openxmlformats.org/drawingml/2006/main" xmlns:p="http://schemas.openxmlformats.org/presentationml/2006/main" xmlns:r="http://schemas.openxmlformats.org/officeDocument/2006/relationships">
+  <p:cSld>
+    <p:spTree>
+      <p:nvGrpSpPr>
+        <p:cNvPr id="1" name=""/>
+        <p:cNvGrpSpPr/>
+        <p:nvPr/>
+      </p:nvGrpSpPr>
+      <p:grpSpPr/>
+      <p:sp>
+        <p:nvSpPr>
+          <p:cNvPr id="2" name="Title 1"/>
+          <p:cNvSpPr>
+            <a:spLocks noGrp="1"/>
+          </p:cNvSpPr>
+          <p:nvPr>
+            <p:ph type="title"/>
+          </p:nvPr>
+        </p:nvSpPr>
+        <p:spPr/>
+        <p:txBody>
+          <a:bodyPr/>
+          <a:lstStyle/>
+          <a:p>
+            <a:r>
+              <a:t>It happened again</a:t>
+            </a:r>
+          </a:p>
+        </p:txBody>
+      </p:sp>
+      <p:sp>
+        <p:nvSpPr>
+          <p:cNvPr id="3" name="Content Placeholder 2"/>
+          <p:cNvSpPr>
+            <a:spLocks noGrp="1"/>
+          </p:cNvSpPr>
+          <p:nvPr>
+            <p:ph idx="1"/>
+          </p:nvPr>
+        </p:nvSpPr>
+        <p:spPr/>
+        <p:txBody>
+          <a:bodyPr wrap="square"/>
+          <a:lstStyle/>
+          <a:p>
+            <a:pPr/>
+            <a:r>
+              <a:rPr sz="2400" b="0"/>
+              <a:t>Two weeks ago, drafting an expansion to more assessment types</a:t>
+            </a:r>
+          </a:p>
+          <a:p>
+            <a:pPr lvl="1"/>
+            <a:r>
+              <a:rPr sz="2000" b="0"/>
+              <a:t>UDL 2.2 names again, and two codes that had moved between versions</a:t>
+            </a:r>
+          </a:p>
+          <a:p>
+            <a:pPr/>
+            <a:r>
+              <a:rPr sz="2400" b="1">
+                <a:solidFill>
+                  <a:srgbClr val="0070C0"/>
+                </a:solidFill>
+              </a:rPr>
+              <a:t>Caught by the check we built the first time, not by anyone being careful</a:t>
+            </a:r>
+          </a:p>
+          <a:p>
+            <a:pPr/>
+            <a:r>
+              <a:rPr sz="2400" b="1"/>
+              <a:t>This isn’t a bug you fix once. It’s a property you design around</a:t>
+            </a:r>
+          </a:p>
+        </p:txBody>
+      </p:sp>
+    </p:spTree>
+  </p:cSld>
+  <p:clrMapOvr>
+    <a:masterClrMapping/>
+  </p:clrMapOvr>
+</p:sld>
+</file>
+
+<file path=ppt/slides/slide8.xml><?xml version="1.0" encoding="utf-8"?>
+<p:sld xmlns:a="http://schemas.openxmlformats.org/drawingml/2006/main" xmlns:p="http://schemas.openxmlformats.org/presentationml/2006/main" xmlns:r="http://schemas.openxmlformats.org/officeDocument/2006/relationships">
+  <p:cSld>
+    <p:spTree>
+      <p:nvGrpSpPr>
+        <p:cNvPr id="1" name=""/>
+        <p:cNvGrpSpPr/>
+        <p:nvPr/>
+      </p:nvGrpSpPr>
+      <p:grpSpPr/>
+      <p:sp>
+        <p:nvSpPr>
+          <p:cNvPr id="2" name="Title 1"/>
+          <p:cNvSpPr>
+            <a:spLocks noGrp="1"/>
+          </p:cNvSpPr>
+          <p:nvPr>
+            <p:ph type="title"/>
+          </p:nvPr>
+        </p:nvSpPr>
+        <p:spPr/>
+        <p:txBody>
+          <a:bodyPr/>
+          <a:lstStyle/>
+          <a:p>
+            <a:r>
+              <a:t>Where it is now, and what transfers</a:t>
+            </a:r>
+          </a:p>
+        </p:txBody>
+      </p:sp>
+      <p:sp>
+        <p:nvSpPr>
+          <p:cNvPr id="3" name="Content Placeholder 2"/>
+          <p:cNvSpPr>
+            <a:spLocks noGrp="1"/>
+          </p:cNvSpPr>
+          <p:nvPr>
+            <p:ph idx="1"/>
+          </p:nvPr>
+        </p:nvSpPr>
+        <p:spPr/>
+        <p:txBody>
+          <a:bodyPr wrap="square"/>
+          <a:lstStyle/>
+          <a:p>
+            <a:pPr/>
+            <a:r>
+              <a:rPr sz="2400" b="1">
+                <a:solidFill>
+                  <a:srgbClr val="0070C0"/>
+                </a:solidFill>
+              </a:rPr>
+              <a:t>The prototype today</a:t>
+            </a:r>
+          </a:p>
+          <a:p>
+            <a:pPr lvl="1"/>
+            <a:r>
+              <a:rPr sz="2000" b="0"/>
+              <a:t>15 assessment types, 57 UDL 3.0 considerations, all nine guidelines</a:t>
+            </a:r>
+          </a:p>
+          <a:p>
+            <a:pPr lvl="1"/>
+            <a:r>
+              <a:rPr sz="2000" b="0"/>
+              <a:t>Every code machine-verified against CAST; live, no login, nothing stored</a:t>
+            </a:r>
+          </a:p>
+          <a:p>
+            <a:pPr lvl="1"/>
+            <a:r>
+              <a:rPr sz="2000" b="0"/>
+              <a:t>Mappings drafted – the pedagogy still needs Luke’s sign-off</a:t>
+            </a:r>
+          </a:p>
+          <a:p>
+            <a:pPr/>
+            <a:r>
+              <a:rPr sz="2400" b="1">
+                <a:solidFill>
+                  <a:srgbClr val="0070C0"/>
+                </a:solidFill>
+              </a:rPr>
+              <a:t>What transfers</a:t>
+            </a:r>
+          </a:p>
+          <a:p>
+            <a:pPr lvl="1"/>
+            <a:r>
+              <a:rPr sz="2000" b="0"/>
+              <a:t>Let AI draft, never decide. Make its claims machine-checkable</a:t>
+            </a:r>
+          </a:p>
+          <a:p>
+            <a:pPr lvl="1"/>
+            <a:r>
+              <a:rPr sz="2000" b="0"/>
+              <a:t>Keep domain authorship human. Expect plausible-and-wrong, and design for it</a:t>
+            </a:r>
+          </a:p>
+        </p:txBody>
+      </p:sp>
+    </p:spTree>
+  </p:cSld>
+  <p:clrMapOvr>
+    <a:masterClrMapping/>
+  </p:clrMapOvr>
+</p:sld>
+</file>
+
+<file path=ppt/slides/slide9.xml><?xml version="1.0" encoding="utf-8"?>
+<p:sld xmlns:a="http://schemas.openxmlformats.org/drawingml/2006/main" xmlns:p="http://schemas.openxmlformats.org/presentationml/2006/main" xmlns:r="http://schemas.openxmlformats.org/officeDocument/2006/relationships">
+  <p:cSld>
+    <p:spTree>
+      <p:nvGrpSpPr>
+        <p:cNvPr id="1" name=""/>
+        <p:cNvGrpSpPr/>
+        <p:nvPr/>
+      </p:nvGrpSpPr>
+      <p:grpSpPr/>
+      <p:sp>
+        <p:nvSpPr>
+          <p:cNvPr id="2" name="Title 1"/>
+          <p:cNvSpPr>
+            <a:spLocks noGrp="1"/>
+          </p:cNvSpPr>
+          <p:nvPr>
+            <p:ph type="title"/>
+          </p:nvPr>
+        </p:nvSpPr>
+        <p:spPr/>
+        <p:txBody>
+          <a:bodyPr/>
+          <a:lstStyle/>
+          <a:p>
+            <a:r>
               <a:t>One of these four is invented</a:t>
             </a:r>
           </a:p>
@@ -5294,620 +5909,6 @@
             <a:r>
               <a:rPr sz="1800" b="1"/>
               <a:t>code A1RHE7</a:t>
-            </a:r>
-          </a:p>
-        </p:txBody>
-      </p:sp>
-    </p:spTree>
-  </p:cSld>
-  <p:clrMapOvr>
-    <a:masterClrMapping/>
-  </p:clrMapOvr>
-</p:sld>
-</file>
-
-<file path=ppt/slides/slide5.xml><?xml version="1.0" encoding="utf-8"?>
-<p:sld xmlns:a="http://schemas.openxmlformats.org/drawingml/2006/main" xmlns:p="http://schemas.openxmlformats.org/presentationml/2006/main" xmlns:r="http://schemas.openxmlformats.org/officeDocument/2006/relationships">
-  <p:cSld>
-    <p:spTree>
-      <p:nvGrpSpPr>
-        <p:cNvPr id="1" name=""/>
-        <p:cNvGrpSpPr/>
-        <p:nvPr/>
-      </p:nvGrpSpPr>
-      <p:grpSpPr/>
-      <p:sp>
-        <p:nvSpPr>
-          <p:cNvPr id="2" name="Title 1"/>
-          <p:cNvSpPr>
-            <a:spLocks noGrp="1"/>
-          </p:cNvSpPr>
-          <p:nvPr>
-            <p:ph type="title"/>
-          </p:nvPr>
-        </p:nvSpPr>
-        <p:spPr/>
-        <p:txBody>
-          <a:bodyPr/>
-          <a:lstStyle/>
-          <a:p>
-            <a:r>
-              <a:t>16 of 21 codes were wrong</a:t>
-            </a:r>
-          </a:p>
-        </p:txBody>
-      </p:sp>
-      <p:sp>
-        <p:nvSpPr>
-          <p:cNvPr id="3" name="Content Placeholder 2"/>
-          <p:cNvSpPr>
-            <a:spLocks noGrp="1"/>
-          </p:cNvSpPr>
-          <p:nvPr>
-            <p:ph idx="1"/>
-          </p:nvPr>
-        </p:nvSpPr>
-        <p:spPr/>
-        <p:txBody>
-          <a:bodyPr wrap="square"/>
-          <a:lstStyle/>
-          <a:p>
-            <a:pPr/>
-            <a:r>
-              <a:rPr sz="2400" b="1">
-                <a:solidFill>
-                  <a:srgbClr val="0070C0"/>
-                </a:solidFill>
-              </a:rPr>
-              <a:t>Luke read the checkpoint data properly in May, and caught it</a:t>
-            </a:r>
-          </a:p>
-          <a:p>
-            <a:pPr/>
-            <a:r>
-              <a:rPr sz="2400" b="1"/>
-              <a:t>16 of our 21 UDL codes were wrong</a:t>
-            </a:r>
-          </a:p>
-          <a:p>
-            <a:pPr lvl="1"/>
-            <a:r>
-              <a:rPr sz="2000" b="0"/>
-              <a:t>UDL 2.2 leftovers, and codes the model appears to have invented</a:t>
-            </a:r>
-          </a:p>
-          <a:p>
-            <a:pPr/>
-            <a:r>
-              <a:rPr sz="2400" b="0"/>
-              <a:t>He spotted it from a single entry: our “3.2 Explicit success criteria and rubric”</a:t>
-            </a:r>
-          </a:p>
-          <a:p>
-            <a:pPr lvl="1"/>
-            <a:r>
-              <a:rPr sz="2000" b="0"/>
-              <a:t>CAST’s actual 3.2 says nothing of the kind</a:t>
-            </a:r>
-          </a:p>
-        </p:txBody>
-      </p:sp>
-    </p:spTree>
-  </p:cSld>
-  <p:clrMapOvr>
-    <a:masterClrMapping/>
-  </p:clrMapOvr>
-</p:sld>
-</file>
-
-<file path=ppt/slides/slide6.xml><?xml version="1.0" encoding="utf-8"?>
-<p:sld xmlns:a="http://schemas.openxmlformats.org/drawingml/2006/main" xmlns:p="http://schemas.openxmlformats.org/presentationml/2006/main" xmlns:r="http://schemas.openxmlformats.org/officeDocument/2006/relationships">
-  <p:cSld>
-    <p:spTree>
-      <p:nvGrpSpPr>
-        <p:cNvPr id="1" name=""/>
-        <p:cNvGrpSpPr/>
-        <p:nvPr/>
-      </p:nvGrpSpPr>
-      <p:grpSpPr/>
-      <p:sp>
-        <p:nvSpPr>
-          <p:cNvPr id="2" name="Title 1"/>
-          <p:cNvSpPr>
-            <a:spLocks noGrp="1"/>
-          </p:cNvSpPr>
-          <p:nvPr>
-            <p:ph type="title"/>
-          </p:nvPr>
-        </p:nvSpPr>
-        <p:spPr/>
-        <p:txBody>
-          <a:bodyPr/>
-          <a:lstStyle/>
-          <a:p>
-            <a:r>
-              <a:t>It didn’t look wrong</a:t>
-            </a:r>
-          </a:p>
-        </p:txBody>
-      </p:sp>
-      <p:sp>
-        <p:nvSpPr>
-          <p:cNvPr id="3" name="Text Placeholder 2"/>
-          <p:cNvSpPr>
-            <a:spLocks noGrp="1"/>
-          </p:cNvSpPr>
-          <p:nvPr>
-            <p:ph type="body" idx="1"/>
-          </p:nvPr>
-        </p:nvSpPr>
-        <p:spPr/>
-        <p:txBody>
-          <a:bodyPr/>
-          <a:lstStyle/>
-          <a:p>
-            <a:r>
-              <a:rPr sz="2000" b="1">
-                <a:solidFill>
-                  <a:srgbClr val="0070C0"/>
-                </a:solidFill>
-              </a:rPr>
-              <a:t>What we shipped</a:t>
-            </a:r>
-          </a:p>
-        </p:txBody>
-      </p:sp>
-      <p:sp>
-        <p:nvSpPr>
-          <p:cNvPr id="4" name="Content Placeholder 3"/>
-          <p:cNvSpPr>
-            <a:spLocks noGrp="1"/>
-          </p:cNvSpPr>
-          <p:nvPr>
-            <p:ph idx="2" sz="half"/>
-          </p:nvPr>
-        </p:nvSpPr>
-        <p:spPr/>
-        <p:txBody>
-          <a:bodyPr wrap="square"/>
-          <a:lstStyle/>
-          <a:p>
-            <a:r>
-              <a:rPr sz="1800" b="0"/>
-              <a:t>3.2  Explicit success criteria and rubric</a:t>
-            </a:r>
-          </a:p>
-          <a:p>
-            <a:pPr>
-              <a:spcBef>
-                <a:spcPts val="1000"/>
-              </a:spcBef>
-            </a:pPr>
-            <a:r>
-              <a:rPr sz="1800" b="0"/>
-              <a:t>1.3  Brief meets accessibility standards</a:t>
-            </a:r>
-          </a:p>
-          <a:p>
-            <a:pPr>
-              <a:spcBef>
-                <a:spcPts val="1000"/>
-              </a:spcBef>
-            </a:pPr>
-            <a:r>
-              <a:rPr sz="1800" b="0"/>
-              <a:t>9.2  No assumed socioeconomic advantage</a:t>
-            </a:r>
-          </a:p>
-          <a:p>
-            <a:pPr>
-              <a:spcBef>
-                <a:spcPts val="1000"/>
-              </a:spcBef>
-            </a:pPr>
-            <a:r>
-              <a:rPr sz="1800" b="1"/>
-              <a:t>4.3  Technology requirements clearly stated</a:t>
-            </a:r>
-          </a:p>
-        </p:txBody>
-      </p:sp>
-      <p:sp>
-        <p:nvSpPr>
-          <p:cNvPr id="5" name="Text Placeholder 4"/>
-          <p:cNvSpPr>
-            <a:spLocks noGrp="1"/>
-          </p:cNvSpPr>
-          <p:nvPr>
-            <p:ph type="body" idx="3" sz="quarter"/>
-          </p:nvPr>
-        </p:nvSpPr>
-        <p:spPr/>
-        <p:txBody>
-          <a:bodyPr/>
-          <a:lstStyle/>
-          <a:p>
-            <a:r>
-              <a:rPr sz="2000" b="1">
-                <a:solidFill>
-                  <a:srgbClr val="0070C0"/>
-                </a:solidFill>
-              </a:rPr>
-              <a:t>What UDL 3.0 actually says</a:t>
-            </a:r>
-          </a:p>
-        </p:txBody>
-      </p:sp>
-      <p:sp>
-        <p:nvSpPr>
-          <p:cNvPr id="6" name="Content Placeholder 5"/>
-          <p:cNvSpPr>
-            <a:spLocks noGrp="1"/>
-          </p:cNvSpPr>
-          <p:nvPr>
-            <p:ph idx="4" sz="quarter"/>
-          </p:nvPr>
-        </p:nvSpPr>
-        <p:spPr/>
-        <p:txBody>
-          <a:bodyPr wrap="square"/>
-          <a:lstStyle/>
-          <a:p>
-            <a:r>
-              <a:rPr sz="1800" b="0"/>
-              <a:t>Highlight patterns and big ideas</a:t>
-            </a:r>
-          </a:p>
-          <a:p>
-            <a:pPr>
-              <a:spcBef>
-                <a:spcPts val="1000"/>
-              </a:spcBef>
-            </a:pPr>
-            <a:r>
-              <a:rPr sz="1800" b="0"/>
-              <a:t>Represent diverse perspectives and identities</a:t>
-            </a:r>
-          </a:p>
-          <a:p>
-            <a:pPr>
-              <a:spcBef>
-                <a:spcPts val="1000"/>
-              </a:spcBef>
-            </a:pPr>
-            <a:r>
-              <a:rPr sz="1800" b="0"/>
-              <a:t>Develop awareness of self and others</a:t>
-            </a:r>
-          </a:p>
-          <a:p>
-            <a:pPr>
-              <a:spcBef>
-                <a:spcPts val="1000"/>
-              </a:spcBef>
-            </a:pPr>
-            <a:r>
-              <a:rPr sz="1800" b="1"/>
-              <a:t>There is no 4.3. Guideline 4 stops at 4.2</a:t>
-            </a:r>
-          </a:p>
-        </p:txBody>
-      </p:sp>
-      <p:sp>
-        <p:nvSpPr>
-          <p:cNvPr id="7" name="TextBox 6"/>
-          <p:cNvSpPr txBox="1"/>
-          <p:nvPr/>
-        </p:nvSpPr>
-        <p:spPr>
-          <a:xfrm>
-            <a:off x="841248" y="4892040"/>
-            <a:ext cx="10515600" cy="548640"/>
-          </a:xfrm>
-          <a:prstGeom prst="rect">
-            <a:avLst/>
-          </a:prstGeom>
-          <a:noFill/>
-        </p:spPr>
-        <p:txBody>
-          <a:bodyPr wrap="square" lIns="0" tIns="0" bIns="0">
-            <a:spAutoFit/>
-          </a:bodyPr>
-          <a:lstStyle/>
-          <a:p>
-            <a:r>
-              <a:rPr sz="2000" b="1">
-                <a:solidFill>
-                  <a:srgbClr val="0070C0"/>
-                </a:solidFill>
-              </a:rPr>
-              <a:t>Plausible, well formatted, confidently numbered, and wrong.</a:t>
-            </a:r>
-          </a:p>
-        </p:txBody>
-      </p:sp>
-    </p:spTree>
-  </p:cSld>
-  <p:clrMapOvr>
-    <a:masterClrMapping/>
-  </p:clrMapOvr>
-</p:sld>
-</file>
-
-<file path=ppt/slides/slide7.xml><?xml version="1.0" encoding="utf-8"?>
-<p:sld xmlns:a="http://schemas.openxmlformats.org/drawingml/2006/main" xmlns:p="http://schemas.openxmlformats.org/presentationml/2006/main" xmlns:r="http://schemas.openxmlformats.org/officeDocument/2006/relationships">
-  <p:cSld>
-    <p:spTree>
-      <p:nvGrpSpPr>
-        <p:cNvPr id="1" name=""/>
-        <p:cNvGrpSpPr/>
-        <p:nvPr/>
-      </p:nvGrpSpPr>
-      <p:grpSpPr/>
-      <p:sp>
-        <p:nvSpPr>
-          <p:cNvPr id="2" name="Title 1"/>
-          <p:cNvSpPr>
-            <a:spLocks noGrp="1"/>
-          </p:cNvSpPr>
-          <p:nvPr>
-            <p:ph type="title"/>
-          </p:nvPr>
-        </p:nvSpPr>
-        <p:spPr/>
-        <p:txBody>
-          <a:bodyPr/>
-          <a:lstStyle/>
-          <a:p>
-            <a:r>
-              <a:t>The reset</a:t>
-            </a:r>
-          </a:p>
-        </p:txBody>
-      </p:sp>
-      <p:sp>
-        <p:nvSpPr>
-          <p:cNvPr id="3" name="Content Placeholder 2"/>
-          <p:cNvSpPr>
-            <a:spLocks noGrp="1"/>
-          </p:cNvSpPr>
-          <p:nvPr>
-            <p:ph idx="1"/>
-          </p:nvPr>
-        </p:nvSpPr>
-        <p:spPr/>
-        <p:txBody>
-          <a:bodyPr wrap="square"/>
-          <a:lstStyle/>
-          <a:p>
-            <a:pPr/>
-            <a:r>
-              <a:rPr sz="2400" b="0"/>
-              <a:t>Stripped back to six – only considerations Luke had verified against CAST</a:t>
-            </a:r>
-          </a:p>
-          <a:p>
-            <a:pPr/>
-            <a:r>
-              <a:rPr sz="2400" b="0"/>
-              <a:t>Made the codes checkable – every code now validates against a canonical UDL 3.0 table</a:t>
-            </a:r>
-          </a:p>
-          <a:p>
-            <a:pPr/>
-            <a:r>
-              <a:rPr sz="2400" b="1">
-                <a:solidFill>
-                  <a:srgbClr val="0070C0"/>
-                </a:solidFill>
-              </a:rPr>
-              <a:t>Took the pedagogy off the model – the practices are written by someone who teaches</a:t>
-            </a:r>
-          </a:p>
-          <a:p>
-            <a:pPr/>
-            <a:r>
-              <a:rPr sz="2400" b="0"/>
-              <a:t>Kept the receipts – the 21-checkpoint version is still in git history</a:t>
-            </a:r>
-          </a:p>
-        </p:txBody>
-      </p:sp>
-    </p:spTree>
-  </p:cSld>
-  <p:clrMapOvr>
-    <a:masterClrMapping/>
-  </p:clrMapOvr>
-</p:sld>
-</file>
-
-<file path=ppt/slides/slide8.xml><?xml version="1.0" encoding="utf-8"?>
-<p:sld xmlns:a="http://schemas.openxmlformats.org/drawingml/2006/main" xmlns:p="http://schemas.openxmlformats.org/presentationml/2006/main" xmlns:r="http://schemas.openxmlformats.org/officeDocument/2006/relationships">
-  <p:cSld>
-    <p:spTree>
-      <p:nvGrpSpPr>
-        <p:cNvPr id="1" name=""/>
-        <p:cNvGrpSpPr/>
-        <p:nvPr/>
-      </p:nvGrpSpPr>
-      <p:grpSpPr/>
-      <p:sp>
-        <p:nvSpPr>
-          <p:cNvPr id="2" name="Title 1"/>
-          <p:cNvSpPr>
-            <a:spLocks noGrp="1"/>
-          </p:cNvSpPr>
-          <p:nvPr>
-            <p:ph type="title"/>
-          </p:nvPr>
-        </p:nvSpPr>
-        <p:spPr/>
-        <p:txBody>
-          <a:bodyPr/>
-          <a:lstStyle/>
-          <a:p>
-            <a:r>
-              <a:t>It happened again</a:t>
-            </a:r>
-          </a:p>
-        </p:txBody>
-      </p:sp>
-      <p:sp>
-        <p:nvSpPr>
-          <p:cNvPr id="3" name="Content Placeholder 2"/>
-          <p:cNvSpPr>
-            <a:spLocks noGrp="1"/>
-          </p:cNvSpPr>
-          <p:nvPr>
-            <p:ph idx="1"/>
-          </p:nvPr>
-        </p:nvSpPr>
-        <p:spPr/>
-        <p:txBody>
-          <a:bodyPr wrap="square"/>
-          <a:lstStyle/>
-          <a:p>
-            <a:pPr/>
-            <a:r>
-              <a:rPr sz="2400" b="0"/>
-              <a:t>Two weeks ago, drafting an expansion to more assessment types</a:t>
-            </a:r>
-          </a:p>
-          <a:p>
-            <a:pPr lvl="1"/>
-            <a:r>
-              <a:rPr sz="2000" b="0"/>
-              <a:t>UDL 2.2 names again, and two codes that had moved between versions</a:t>
-            </a:r>
-          </a:p>
-          <a:p>
-            <a:pPr/>
-            <a:r>
-              <a:rPr sz="2400" b="1">
-                <a:solidFill>
-                  <a:srgbClr val="0070C0"/>
-                </a:solidFill>
-              </a:rPr>
-              <a:t>Caught by the check we built the first time, not by anyone being careful</a:t>
-            </a:r>
-          </a:p>
-          <a:p>
-            <a:pPr/>
-            <a:r>
-              <a:rPr sz="2400" b="1"/>
-              <a:t>This isn’t a bug you fix once. It’s a property you design around</a:t>
-            </a:r>
-          </a:p>
-        </p:txBody>
-      </p:sp>
-    </p:spTree>
-  </p:cSld>
-  <p:clrMapOvr>
-    <a:masterClrMapping/>
-  </p:clrMapOvr>
-</p:sld>
-</file>
-
-<file path=ppt/slides/slide9.xml><?xml version="1.0" encoding="utf-8"?>
-<p:sld xmlns:a="http://schemas.openxmlformats.org/drawingml/2006/main" xmlns:p="http://schemas.openxmlformats.org/presentationml/2006/main" xmlns:r="http://schemas.openxmlformats.org/officeDocument/2006/relationships">
-  <p:cSld>
-    <p:spTree>
-      <p:nvGrpSpPr>
-        <p:cNvPr id="1" name=""/>
-        <p:cNvGrpSpPr/>
-        <p:nvPr/>
-      </p:nvGrpSpPr>
-      <p:grpSpPr/>
-      <p:sp>
-        <p:nvSpPr>
-          <p:cNvPr id="2" name="Title 1"/>
-          <p:cNvSpPr>
-            <a:spLocks noGrp="1"/>
-          </p:cNvSpPr>
-          <p:nvPr>
-            <p:ph type="title"/>
-          </p:nvPr>
-        </p:nvSpPr>
-        <p:spPr/>
-        <p:txBody>
-          <a:bodyPr/>
-          <a:lstStyle/>
-          <a:p>
-            <a:r>
-              <a:t>Where it is now, and what transfers</a:t>
-            </a:r>
-          </a:p>
-        </p:txBody>
-      </p:sp>
-      <p:sp>
-        <p:nvSpPr>
-          <p:cNvPr id="3" name="Content Placeholder 2"/>
-          <p:cNvSpPr>
-            <a:spLocks noGrp="1"/>
-          </p:cNvSpPr>
-          <p:nvPr>
-            <p:ph idx="1"/>
-          </p:nvPr>
-        </p:nvSpPr>
-        <p:spPr/>
-        <p:txBody>
-          <a:bodyPr wrap="square"/>
-          <a:lstStyle/>
-          <a:p>
-            <a:pPr/>
-            <a:r>
-              <a:rPr sz="2400" b="1">
-                <a:solidFill>
-                  <a:srgbClr val="0070C0"/>
-                </a:solidFill>
-              </a:rPr>
-              <a:t>The prototype today</a:t>
-            </a:r>
-          </a:p>
-          <a:p>
-            <a:pPr lvl="1"/>
-            <a:r>
-              <a:rPr sz="2000" b="0"/>
-              <a:t>15 assessment types, 57 UDL 3.0 considerations, all nine guidelines</a:t>
-            </a:r>
-          </a:p>
-          <a:p>
-            <a:pPr lvl="1"/>
-            <a:r>
-              <a:rPr sz="2000" b="0"/>
-              <a:t>Every code machine-verified against CAST; live, no login, nothing stored</a:t>
-            </a:r>
-          </a:p>
-          <a:p>
-            <a:pPr lvl="1"/>
-            <a:r>
-              <a:rPr sz="2000" b="0"/>
-              <a:t>Mappings drafted – the pedagogy still needs Luke’s sign-off</a:t>
-            </a:r>
-          </a:p>
-          <a:p>
-            <a:pPr/>
-            <a:r>
-              <a:rPr sz="2400" b="1">
-                <a:solidFill>
-                  <a:srgbClr val="0070C0"/>
-                </a:solidFill>
-              </a:rPr>
-              <a:t>What transfers</a:t>
-            </a:r>
-          </a:p>
-          <a:p>
-            <a:pPr lvl="1"/>
-            <a:r>
-              <a:rPr sz="2000" b="0"/>
-              <a:t>Let AI draft, never decide. Make its claims machine-checkable</a:t>
-            </a:r>
-          </a:p>
-          <a:p>
-            <a:pPr lvl="1"/>
-            <a:r>
-              <a:rPr sz="2000" b="0"/>
-              <a:t>Keep domain authorship human. Expect plausible-and-wrong, and design for it</a:t>
             </a:r>
           </a:p>
         </p:txBody>

</xml_diff>